<commit_message>
fix: restructure and correct SQL Server documentation
</commit_message>
<xml_diff>
--- a/sqlserver-sql/presentation/sqlserver-datatypes.pptx
+++ b/sqlserver-sql/presentation/sqlserver-datatypes.pptx
@@ -4880,11 +4880,11 @@
             <a:pPr lvl="1"/>
             <a:r>
               <a:rPr sz="1800" b="1" dirty="0"/>
-              <a:t>DECIMAL</a:t>
+              <a:t>DECIMAL - Stores exact numbers with fixed precision and scale. For example, DECIMAL(5,2) can store values from -999.99 to 999.99.</a:t>
             </a:r>
             <a:r>
               <a:rPr sz="1800" dirty="0"/>
-              <a:t> - Stores numbers with a fixed number of decimal places. For example, DECIMAL(5,2) can store numbers from -9999.99 to 9999.99.</a:t>
+              <a:t/>
             </a:r>
           </a:p>
           <a:p>
@@ -5129,11 +5129,11 @@
             <a:pPr lvl="1"/>
             <a:r>
               <a:rPr sz="1800" b="1" dirty="0"/>
-              <a:t>NUMERIC</a:t>
+              <a:t>NUMERIC - A synonym for DECIMAL; stores exact numbers with fixed precision and scale.</a:t>
             </a:r>
             <a:r>
               <a:rPr sz="1800" dirty="0"/>
-              <a:t> - Stores numbers with a variable number of decimal places.</a:t>
+              <a:t/>
             </a:r>
           </a:p>
           <a:p>
@@ -5962,11 +5962,11 @@
             <a:pPr lvl="1"/>
             <a:r>
               <a:rPr lang="en-IN" sz="1800" b="1" dirty="0"/>
-              <a:t>TEXT</a:t>
+              <a:t>TEXT - Stores variable-length non-Unicode text up to 2^31-1 bytes. It is deprecated; use VARCHAR(MAX) for new development.</a:t>
             </a:r>
             <a:r>
               <a:rPr lang="en-IN" sz="1800" dirty="0"/>
-              <a:t> - Stores variable-length strings without any length limit.</a:t>
+              <a:t/>
             </a:r>
           </a:p>
           <a:p>

</xml_diff>